<commit_message>
fix: update WarriorFit presentation file (NL)
</commit_message>
<xml_diff>
--- a/documentation/WarriorFit_Presentatie_10min_NL.pptx
+++ b/documentation/WarriorFit_Presentatie_10min_NL.pptx
@@ -319,7 +319,7 @@
           <a:p>
             <a:fld id="{5BCAD085-E8A6-8845-BD4E-CB4CCA059FC4}" type="datetimeFigureOut">
               <a:rPr lang="en-US" smtClean="0"/>
-              <a:t>5/31/26</a:t>
+              <a:t>6/14/26</a:t>
             </a:fld>
             <a:endParaRPr lang="en-US"/>
           </a:p>
@@ -487,7 +487,7 @@
           <a:p>
             <a:fld id="{5BCAD085-E8A6-8845-BD4E-CB4CCA059FC4}" type="datetimeFigureOut">
               <a:rPr lang="en-US" smtClean="0"/>
-              <a:t>5/31/26</a:t>
+              <a:t>6/14/26</a:t>
             </a:fld>
             <a:endParaRPr lang="en-US"/>
           </a:p>
@@ -665,7 +665,7 @@
           <a:p>
             <a:fld id="{5BCAD085-E8A6-8845-BD4E-CB4CCA059FC4}" type="datetimeFigureOut">
               <a:rPr lang="en-US" smtClean="0"/>
-              <a:t>5/31/26</a:t>
+              <a:t>6/14/26</a:t>
             </a:fld>
             <a:endParaRPr lang="en-US"/>
           </a:p>
@@ -833,7 +833,7 @@
           <a:p>
             <a:fld id="{5BCAD085-E8A6-8845-BD4E-CB4CCA059FC4}" type="datetimeFigureOut">
               <a:rPr lang="en-US" smtClean="0"/>
-              <a:t>5/31/26</a:t>
+              <a:t>6/14/26</a:t>
             </a:fld>
             <a:endParaRPr lang="en-US"/>
           </a:p>
@@ -1078,7 +1078,7 @@
           <a:p>
             <a:fld id="{5BCAD085-E8A6-8845-BD4E-CB4CCA059FC4}" type="datetimeFigureOut">
               <a:rPr lang="en-US" smtClean="0"/>
-              <a:t>5/31/26</a:t>
+              <a:t>6/14/26</a:t>
             </a:fld>
             <a:endParaRPr lang="en-US"/>
           </a:p>
@@ -1363,7 +1363,7 @@
           <a:p>
             <a:fld id="{5BCAD085-E8A6-8845-BD4E-CB4CCA059FC4}" type="datetimeFigureOut">
               <a:rPr lang="en-US" smtClean="0"/>
-              <a:t>5/31/26</a:t>
+              <a:t>6/14/26</a:t>
             </a:fld>
             <a:endParaRPr lang="en-US"/>
           </a:p>
@@ -1782,7 +1782,7 @@
           <a:p>
             <a:fld id="{5BCAD085-E8A6-8845-BD4E-CB4CCA059FC4}" type="datetimeFigureOut">
               <a:rPr lang="en-US" smtClean="0"/>
-              <a:t>5/31/26</a:t>
+              <a:t>6/14/26</a:t>
             </a:fld>
             <a:endParaRPr lang="en-US"/>
           </a:p>
@@ -1899,7 +1899,7 @@
           <a:p>
             <a:fld id="{5BCAD085-E8A6-8845-BD4E-CB4CCA059FC4}" type="datetimeFigureOut">
               <a:rPr lang="en-US" smtClean="0"/>
-              <a:t>5/31/26</a:t>
+              <a:t>6/14/26</a:t>
             </a:fld>
             <a:endParaRPr lang="en-US"/>
           </a:p>
@@ -1994,7 +1994,7 @@
           <a:p>
             <a:fld id="{5BCAD085-E8A6-8845-BD4E-CB4CCA059FC4}" type="datetimeFigureOut">
               <a:rPr lang="en-US" smtClean="0"/>
-              <a:t>5/31/26</a:t>
+              <a:t>6/14/26</a:t>
             </a:fld>
             <a:endParaRPr lang="en-US"/>
           </a:p>
@@ -2269,7 +2269,7 @@
           <a:p>
             <a:fld id="{5BCAD085-E8A6-8845-BD4E-CB4CCA059FC4}" type="datetimeFigureOut">
               <a:rPr lang="en-US" smtClean="0"/>
-              <a:t>5/31/26</a:t>
+              <a:t>6/14/26</a:t>
             </a:fld>
             <a:endParaRPr lang="en-US"/>
           </a:p>
@@ -2521,7 +2521,7 @@
           <a:p>
             <a:fld id="{5BCAD085-E8A6-8845-BD4E-CB4CCA059FC4}" type="datetimeFigureOut">
               <a:rPr lang="en-US" smtClean="0"/>
-              <a:t>5/31/26</a:t>
+              <a:t>6/14/26</a:t>
             </a:fld>
             <a:endParaRPr lang="en-US"/>
           </a:p>
@@ -2732,7 +2732,7 @@
           <a:p>
             <a:fld id="{5BCAD085-E8A6-8845-BD4E-CB4CCA059FC4}" type="datetimeFigureOut">
               <a:rPr lang="en-US" smtClean="0"/>
-              <a:t>5/31/26</a:t>
+              <a:t>6/14/26</a:t>
             </a:fld>
             <a:endParaRPr lang="en-US"/>
           </a:p>
@@ -15185,8 +15185,8 @@
         </p:blipFill>
         <p:spPr>
           <a:xfrm>
-            <a:off x="274320" y="1234440"/>
-            <a:ext cx="6858000" cy="3644774"/>
+            <a:off x="274318" y="1234439"/>
+            <a:ext cx="7271617" cy="3696483"/>
           </a:xfrm>
           <a:prstGeom prst="rect">
             <a:avLst/>
@@ -15201,8 +15201,8 @@
         </p:nvSpPr>
         <p:spPr>
           <a:xfrm>
-            <a:off x="7498079" y="1234440"/>
-            <a:ext cx="4434840" cy="5394960"/>
+            <a:off x="7680959" y="1234439"/>
+            <a:ext cx="4181883" cy="5394960"/>
           </a:xfrm>
           <a:prstGeom prst="rect">
             <a:avLst/>
@@ -15261,7 +15261,7 @@
           <a:p>
             <a:pPr algn="l"/>
             <a:r>
-              <a:rPr sz="1500" b="1" i="0">
+              <a:rPr sz="1500" b="1" i="0" dirty="0">
                 <a:solidFill>
                   <a:srgbClr val="C8A020"/>
                 </a:solidFill>
@@ -15300,14 +15300,56 @@
               </a:spcAft>
             </a:pPr>
             <a:r>
-              <a:rPr sz="1200">
+              <a:rPr sz="1200" dirty="0" err="1">
                 <a:solidFill>
                   <a:srgbClr val="B0C09A"/>
                 </a:solidFill>
                 <a:latin typeface="Calibri"/>
               </a:rPr>
-              <a:t>providers.Singleton(…) — gedeeld over proceslevensduur</a:t>
-            </a:r>
+              <a:t>providers.Singleton</a:t>
+            </a:r>
+            <a:r>
+              <a:rPr sz="1200" dirty="0">
+                <a:solidFill>
+                  <a:srgbClr val="B0C09A"/>
+                </a:solidFill>
+                <a:latin typeface="Calibri"/>
+              </a:rPr>
+              <a:t>(…) — </a:t>
+            </a:r>
+            <a:r>
+              <a:rPr sz="1200" dirty="0" err="1">
+                <a:solidFill>
+                  <a:srgbClr val="B0C09A"/>
+                </a:solidFill>
+                <a:latin typeface="Calibri"/>
+              </a:rPr>
+              <a:t>gedeeld</a:t>
+            </a:r>
+            <a:r>
+              <a:rPr sz="1200" dirty="0">
+                <a:solidFill>
+                  <a:srgbClr val="B0C09A"/>
+                </a:solidFill>
+                <a:latin typeface="Calibri"/>
+              </a:rPr>
+              <a:t> over </a:t>
+            </a:r>
+            <a:r>
+              <a:rPr sz="1200" dirty="0" err="1">
+                <a:solidFill>
+                  <a:srgbClr val="B0C09A"/>
+                </a:solidFill>
+                <a:latin typeface="Calibri"/>
+              </a:rPr>
+              <a:t>proceslevensduur</a:t>
+            </a:r>
+            <a:endParaRPr sz="1200" dirty="0">
+              <a:solidFill>
+                <a:srgbClr val="B0C09A"/>
+              </a:solidFill>
+              <a:latin typeface="Calibri"/>
+            </a:endParaRPr>
           </a:p>
           <a:p>
             <a:pPr algn="l">
@@ -15315,7 +15357,7 @@
                 <a:spcPts val="500"/>
               </a:spcAft>
             </a:pPr>
-            <a:endParaRPr sz="1200">
+            <a:endParaRPr sz="1200" dirty="0">
               <a:solidFill>
                 <a:srgbClr val="B0C09A"/>
               </a:solidFill>
@@ -15329,13 +15371,49 @@
               </a:spcAft>
             </a:pPr>
             <a:r>
-              <a:rPr sz="1200">
+              <a:rPr sz="1200" dirty="0">
                 <a:solidFill>
                   <a:srgbClr val="B0C09A"/>
                 </a:solidFill>
                 <a:latin typeface="Calibri"/>
               </a:rPr>
-              <a:t>Repositories (8):  UserRepository, FitnessTestRepository …</a:t>
+              <a:t>Repositories (8):  </a:t>
+            </a:r>
+            <a:r>
+              <a:rPr sz="1200" dirty="0" err="1">
+                <a:solidFill>
+                  <a:srgbClr val="B0C09A"/>
+                </a:solidFill>
+                <a:latin typeface="Calibri"/>
+              </a:rPr>
+              <a:t>UserRepository</a:t>
+            </a:r>
+            <a:r>
+              <a:rPr sz="1200" dirty="0">
+                <a:solidFill>
+                  <a:srgbClr val="B0C09A"/>
+                </a:solidFill>
+                <a:latin typeface="Calibri"/>
+              </a:rPr>
+              <a:t>, </a:t>
+            </a:r>
+            <a:r>
+              <a:rPr sz="1200" dirty="0" err="1">
+                <a:solidFill>
+                  <a:srgbClr val="B0C09A"/>
+                </a:solidFill>
+                <a:latin typeface="Calibri"/>
+              </a:rPr>
+              <a:t>FitnessTestRepository</a:t>
+            </a:r>
+            <a:r>
+              <a:rPr sz="1200" dirty="0">
+                <a:solidFill>
+                  <a:srgbClr val="B0C09A"/>
+                </a:solidFill>
+                <a:latin typeface="Calibri"/>
+              </a:rPr>
+              <a:t> …</a:t>
             </a:r>
           </a:p>
           <a:p>
@@ -15345,13 +15423,67 @@
               </a:spcAft>
             </a:pPr>
             <a:r>
-              <a:rPr sz="1200">
+              <a:rPr sz="1200" dirty="0">
                 <a:solidFill>
                   <a:srgbClr val="B0C09A"/>
                 </a:solidFill>
                 <a:latin typeface="Calibri"/>
               </a:rPr>
-              <a:t>Services (12+):    ServiceTest, GdprService, RetentionService …</a:t>
+              <a:t>Services (12+):    </a:t>
+            </a:r>
+            <a:r>
+              <a:rPr sz="1200" dirty="0" err="1">
+                <a:solidFill>
+                  <a:srgbClr val="B0C09A"/>
+                </a:solidFill>
+                <a:latin typeface="Calibri"/>
+              </a:rPr>
+              <a:t>ServiceTest</a:t>
+            </a:r>
+            <a:r>
+              <a:rPr sz="1200" dirty="0">
+                <a:solidFill>
+                  <a:srgbClr val="B0C09A"/>
+                </a:solidFill>
+                <a:latin typeface="Calibri"/>
+              </a:rPr>
+              <a:t>, </a:t>
+            </a:r>
+            <a:r>
+              <a:rPr sz="1200" dirty="0" err="1">
+                <a:solidFill>
+                  <a:srgbClr val="B0C09A"/>
+                </a:solidFill>
+                <a:latin typeface="Calibri"/>
+              </a:rPr>
+              <a:t>GdprService</a:t>
+            </a:r>
+            <a:r>
+              <a:rPr sz="1200" dirty="0">
+                <a:solidFill>
+                  <a:srgbClr val="B0C09A"/>
+                </a:solidFill>
+                <a:latin typeface="Calibri"/>
+              </a:rPr>
+              <a:t>, </a:t>
+            </a:r>
+            <a:r>
+              <a:rPr sz="1200" dirty="0" err="1">
+                <a:solidFill>
+                  <a:srgbClr val="B0C09A"/>
+                </a:solidFill>
+                <a:latin typeface="Calibri"/>
+              </a:rPr>
+              <a:t>RetentionService</a:t>
+            </a:r>
+            <a:r>
+              <a:rPr sz="1200" dirty="0">
+                <a:solidFill>
+                  <a:srgbClr val="B0C09A"/>
+                </a:solidFill>
+                <a:latin typeface="Calibri"/>
+              </a:rPr>
+              <a:t> …</a:t>
             </a:r>
           </a:p>
           <a:p>
@@ -15361,13 +15493,49 @@
               </a:spcAft>
             </a:pPr>
             <a:r>
-              <a:rPr sz="1200">
+              <a:rPr sz="1200" dirty="0">
                 <a:solidFill>
                   <a:srgbClr val="B0C09A"/>
                 </a:solidFill>
                 <a:latin typeface="Calibri"/>
               </a:rPr>
-              <a:t>Controllers (5):   PhefController, CrossController …</a:t>
+              <a:t>Controllers (5):   </a:t>
+            </a:r>
+            <a:r>
+              <a:rPr sz="1200" dirty="0" err="1">
+                <a:solidFill>
+                  <a:srgbClr val="B0C09A"/>
+                </a:solidFill>
+                <a:latin typeface="Calibri"/>
+              </a:rPr>
+              <a:t>PhefController</a:t>
+            </a:r>
+            <a:r>
+              <a:rPr sz="1200" dirty="0">
+                <a:solidFill>
+                  <a:srgbClr val="B0C09A"/>
+                </a:solidFill>
+                <a:latin typeface="Calibri"/>
+              </a:rPr>
+              <a:t>, </a:t>
+            </a:r>
+            <a:r>
+              <a:rPr sz="1200" dirty="0" err="1">
+                <a:solidFill>
+                  <a:srgbClr val="B0C09A"/>
+                </a:solidFill>
+                <a:latin typeface="Calibri"/>
+              </a:rPr>
+              <a:t>CrossController</a:t>
+            </a:r>
+            <a:r>
+              <a:rPr sz="1200" dirty="0">
+                <a:solidFill>
+                  <a:srgbClr val="B0C09A"/>
+                </a:solidFill>
+                <a:latin typeface="Calibri"/>
+              </a:rPr>
+              <a:t> …</a:t>
             </a:r>
           </a:p>
           <a:p>
@@ -15377,14 +15545,65 @@
               </a:spcAft>
             </a:pPr>
             <a:r>
-              <a:rPr sz="1200">
+              <a:rPr sz="1200" dirty="0">
                 <a:solidFill>
                   <a:srgbClr val="B0C09A"/>
                 </a:solidFill>
                 <a:latin typeface="Calibri"/>
               </a:rPr>
-              <a:t>External:          BEMILService, MailService, NotifyMail</a:t>
-            </a:r>
+              <a:t>External:          </a:t>
+            </a:r>
+            <a:r>
+              <a:rPr sz="1200" dirty="0" err="1">
+                <a:solidFill>
+                  <a:srgbClr val="B0C09A"/>
+                </a:solidFill>
+                <a:latin typeface="Calibri"/>
+              </a:rPr>
+              <a:t>BEMILService</a:t>
+            </a:r>
+            <a:r>
+              <a:rPr sz="1200" dirty="0">
+                <a:solidFill>
+                  <a:srgbClr val="B0C09A"/>
+                </a:solidFill>
+                <a:latin typeface="Calibri"/>
+              </a:rPr>
+              <a:t>, </a:t>
+            </a:r>
+            <a:r>
+              <a:rPr sz="1200" dirty="0" err="1">
+                <a:solidFill>
+                  <a:srgbClr val="B0C09A"/>
+                </a:solidFill>
+                <a:latin typeface="Calibri"/>
+              </a:rPr>
+              <a:t>MailService</a:t>
+            </a:r>
+            <a:r>
+              <a:rPr sz="1200" dirty="0">
+                <a:solidFill>
+                  <a:srgbClr val="B0C09A"/>
+                </a:solidFill>
+                <a:latin typeface="Calibri"/>
+              </a:rPr>
+              <a:t>, </a:t>
+            </a:r>
+            <a:r>
+              <a:rPr sz="1200" dirty="0" err="1">
+                <a:solidFill>
+                  <a:srgbClr val="B0C09A"/>
+                </a:solidFill>
+                <a:latin typeface="Calibri"/>
+              </a:rPr>
+              <a:t>NotifyMail</a:t>
+            </a:r>
+            <a:endParaRPr sz="1200" dirty="0">
+              <a:solidFill>
+                <a:srgbClr val="B0C09A"/>
+              </a:solidFill>
+              <a:latin typeface="Calibri"/>
+            </a:endParaRPr>
           </a:p>
           <a:p>
             <a:pPr algn="l">
@@ -15393,13 +15612,31 @@
               </a:spcAft>
             </a:pPr>
             <a:r>
-              <a:rPr sz="1200">
+              <a:rPr sz="1200" dirty="0">
                 <a:solidFill>
                   <a:srgbClr val="B0C09A"/>
                 </a:solidFill>
                 <a:latin typeface="Calibri"/>
               </a:rPr>
-              <a:t>Broker:            Transactionele outbox singleton</a:t>
+              <a:t>Broker:            </a:t>
+            </a:r>
+            <a:r>
+              <a:rPr sz="1200" dirty="0" err="1">
+                <a:solidFill>
+                  <a:srgbClr val="B0C09A"/>
+                </a:solidFill>
+                <a:latin typeface="Calibri"/>
+              </a:rPr>
+              <a:t>Transactionele</a:t>
+            </a:r>
+            <a:r>
+              <a:rPr sz="1200" dirty="0">
+                <a:solidFill>
+                  <a:srgbClr val="B0C09A"/>
+                </a:solidFill>
+                <a:latin typeface="Calibri"/>
+              </a:rPr>
+              <a:t> outbox singleton</a:t>
             </a:r>
           </a:p>
           <a:p>
@@ -15408,7 +15645,7 @@
                 <a:spcPts val="500"/>
               </a:spcAft>
             </a:pPr>
-            <a:endParaRPr sz="1200">
+            <a:endParaRPr sz="1200" dirty="0">
               <a:solidFill>
                 <a:srgbClr val="B0C09A"/>
               </a:solidFill>
@@ -15422,13 +15659,31 @@
               </a:spcAft>
             </a:pPr>
             <a:r>
-              <a:rPr sz="1200">
+              <a:rPr sz="1200" dirty="0">
                 <a:solidFill>
                   <a:srgbClr val="B0C09A"/>
                 </a:solidFill>
                 <a:latin typeface="Calibri"/>
               </a:rPr>
-              <a:t>Wiring: containers.WiringConfiguration(modules=[…])</a:t>
+              <a:t>Wiring: </a:t>
+            </a:r>
+            <a:r>
+              <a:rPr sz="1200" dirty="0" err="1">
+                <a:solidFill>
+                  <a:srgbClr val="B0C09A"/>
+                </a:solidFill>
+                <a:latin typeface="Calibri"/>
+              </a:rPr>
+              <a:t>containers.WiringConfiguration</a:t>
+            </a:r>
+            <a:r>
+              <a:rPr sz="1200" dirty="0">
+                <a:solidFill>
+                  <a:srgbClr val="B0C09A"/>
+                </a:solidFill>
+                <a:latin typeface="Calibri"/>
+              </a:rPr>
+              <a:t>(modules=[…])</a:t>
             </a:r>
           </a:p>
           <a:p>
@@ -15438,14 +15693,65 @@
               </a:spcAft>
             </a:pPr>
             <a:r>
-              <a:rPr sz="1200">
+              <a:rPr sz="1200" dirty="0">
                 <a:solidFill>
                   <a:srgbClr val="B0C09A"/>
                 </a:solidFill>
                 <a:latin typeface="Calibri"/>
               </a:rPr>
-              <a:t>  → 25 UI-modules gepatch bij opstart</a:t>
-            </a:r>
+              <a:t>  → 25 UI-modules </a:t>
+            </a:r>
+            <a:r>
+              <a:rPr sz="1200" dirty="0" err="1">
+                <a:solidFill>
+                  <a:srgbClr val="B0C09A"/>
+                </a:solidFill>
+                <a:latin typeface="Calibri"/>
+              </a:rPr>
+              <a:t>gepatch</a:t>
+            </a:r>
+            <a:r>
+              <a:rPr sz="1200" dirty="0">
+                <a:solidFill>
+                  <a:srgbClr val="B0C09A"/>
+                </a:solidFill>
+                <a:latin typeface="Calibri"/>
+              </a:rPr>
+              <a:t> </a:t>
+            </a:r>
+            <a:r>
+              <a:rPr sz="1200" dirty="0" err="1">
+                <a:solidFill>
+                  <a:srgbClr val="B0C09A"/>
+                </a:solidFill>
+                <a:latin typeface="Calibri"/>
+              </a:rPr>
+              <a:t>bij</a:t>
+            </a:r>
+            <a:r>
+              <a:rPr sz="1200" dirty="0">
+                <a:solidFill>
+                  <a:srgbClr val="B0C09A"/>
+                </a:solidFill>
+                <a:latin typeface="Calibri"/>
+              </a:rPr>
+              <a:t> </a:t>
+            </a:r>
+            <a:r>
+              <a:rPr sz="1200" dirty="0" err="1">
+                <a:solidFill>
+                  <a:srgbClr val="B0C09A"/>
+                </a:solidFill>
+                <a:latin typeface="Calibri"/>
+              </a:rPr>
+              <a:t>opstart</a:t>
+            </a:r>
+            <a:endParaRPr sz="1200" dirty="0">
+              <a:solidFill>
+                <a:srgbClr val="B0C09A"/>
+              </a:solidFill>
+              <a:latin typeface="Calibri"/>
+            </a:endParaRPr>
           </a:p>
           <a:p>
             <a:pPr algn="l">
@@ -15454,13 +15760,49 @@
               </a:spcAft>
             </a:pPr>
             <a:r>
-              <a:rPr sz="1200">
+              <a:rPr sz="1200" dirty="0">
                 <a:solidFill>
                   <a:srgbClr val="B0C09A"/>
                 </a:solidFill>
                 <a:latin typeface="Calibri"/>
               </a:rPr>
-              <a:t>  → @inject + Provide[Container.xxx] op page __init__</a:t>
+              <a:t>  → @inject + Provide[</a:t>
+            </a:r>
+            <a:r>
+              <a:rPr sz="1200" dirty="0" err="1">
+                <a:solidFill>
+                  <a:srgbClr val="B0C09A"/>
+                </a:solidFill>
+                <a:latin typeface="Calibri"/>
+              </a:rPr>
+              <a:t>Container.xxx</a:t>
+            </a:r>
+            <a:r>
+              <a:rPr sz="1200" dirty="0">
+                <a:solidFill>
+                  <a:srgbClr val="B0C09A"/>
+                </a:solidFill>
+                <a:latin typeface="Calibri"/>
+              </a:rPr>
+              <a:t>] op page __</a:t>
+            </a:r>
+            <a:r>
+              <a:rPr sz="1200" dirty="0" err="1">
+                <a:solidFill>
+                  <a:srgbClr val="B0C09A"/>
+                </a:solidFill>
+                <a:latin typeface="Calibri"/>
+              </a:rPr>
+              <a:t>init</a:t>
+            </a:r>
+            <a:r>
+              <a:rPr sz="1200" dirty="0">
+                <a:solidFill>
+                  <a:srgbClr val="B0C09A"/>
+                </a:solidFill>
+                <a:latin typeface="Calibri"/>
+              </a:rPr>
+              <a:t>__</a:t>
             </a:r>
           </a:p>
         </p:txBody>

</xml_diff>

<commit_message>
docs: update evolution timeline with MFFT Eval and Test Analytics integration
Added Phase 6 details to reflect the implementation of MFFT Eval (8-event test type, cluster derivation) and new Analytics features (coverage gauges, trends, histograms). Updated gantt charts, architectural diagrams, complexity growth, and milestone sections.
</commit_message>
<xml_diff>
--- a/documentation/WarriorFit_Presentatie_10min_NL.pptx
+++ b/documentation/WarriorFit_Presentatie_10min_NL.pptx
@@ -319,7 +319,7 @@
           <a:p>
             <a:fld id="{5BCAD085-E8A6-8845-BD4E-CB4CCA059FC4}" type="datetimeFigureOut">
               <a:rPr lang="en-US" smtClean="0"/>
-              <a:t>6/14/26</a:t>
+              <a:t>6/15/26</a:t>
             </a:fld>
             <a:endParaRPr lang="en-US"/>
           </a:p>
@@ -487,7 +487,7 @@
           <a:p>
             <a:fld id="{5BCAD085-E8A6-8845-BD4E-CB4CCA059FC4}" type="datetimeFigureOut">
               <a:rPr lang="en-US" smtClean="0"/>
-              <a:t>6/14/26</a:t>
+              <a:t>6/15/26</a:t>
             </a:fld>
             <a:endParaRPr lang="en-US"/>
           </a:p>
@@ -665,7 +665,7 @@
           <a:p>
             <a:fld id="{5BCAD085-E8A6-8845-BD4E-CB4CCA059FC4}" type="datetimeFigureOut">
               <a:rPr lang="en-US" smtClean="0"/>
-              <a:t>6/14/26</a:t>
+              <a:t>6/15/26</a:t>
             </a:fld>
             <a:endParaRPr lang="en-US"/>
           </a:p>
@@ -833,7 +833,7 @@
           <a:p>
             <a:fld id="{5BCAD085-E8A6-8845-BD4E-CB4CCA059FC4}" type="datetimeFigureOut">
               <a:rPr lang="en-US" smtClean="0"/>
-              <a:t>6/14/26</a:t>
+              <a:t>6/15/26</a:t>
             </a:fld>
             <a:endParaRPr lang="en-US"/>
           </a:p>
@@ -1078,7 +1078,7 @@
           <a:p>
             <a:fld id="{5BCAD085-E8A6-8845-BD4E-CB4CCA059FC4}" type="datetimeFigureOut">
               <a:rPr lang="en-US" smtClean="0"/>
-              <a:t>6/14/26</a:t>
+              <a:t>6/15/26</a:t>
             </a:fld>
             <a:endParaRPr lang="en-US"/>
           </a:p>
@@ -1363,7 +1363,7 @@
           <a:p>
             <a:fld id="{5BCAD085-E8A6-8845-BD4E-CB4CCA059FC4}" type="datetimeFigureOut">
               <a:rPr lang="en-US" smtClean="0"/>
-              <a:t>6/14/26</a:t>
+              <a:t>6/15/26</a:t>
             </a:fld>
             <a:endParaRPr lang="en-US"/>
           </a:p>
@@ -1782,7 +1782,7 @@
           <a:p>
             <a:fld id="{5BCAD085-E8A6-8845-BD4E-CB4CCA059FC4}" type="datetimeFigureOut">
               <a:rPr lang="en-US" smtClean="0"/>
-              <a:t>6/14/26</a:t>
+              <a:t>6/15/26</a:t>
             </a:fld>
             <a:endParaRPr lang="en-US"/>
           </a:p>
@@ -1899,7 +1899,7 @@
           <a:p>
             <a:fld id="{5BCAD085-E8A6-8845-BD4E-CB4CCA059FC4}" type="datetimeFigureOut">
               <a:rPr lang="en-US" smtClean="0"/>
-              <a:t>6/14/26</a:t>
+              <a:t>6/15/26</a:t>
             </a:fld>
             <a:endParaRPr lang="en-US"/>
           </a:p>
@@ -1994,7 +1994,7 @@
           <a:p>
             <a:fld id="{5BCAD085-E8A6-8845-BD4E-CB4CCA059FC4}" type="datetimeFigureOut">
               <a:rPr lang="en-US" smtClean="0"/>
-              <a:t>6/14/26</a:t>
+              <a:t>6/15/26</a:t>
             </a:fld>
             <a:endParaRPr lang="en-US"/>
           </a:p>
@@ -2269,7 +2269,7 @@
           <a:p>
             <a:fld id="{5BCAD085-E8A6-8845-BD4E-CB4CCA059FC4}" type="datetimeFigureOut">
               <a:rPr lang="en-US" smtClean="0"/>
-              <a:t>6/14/26</a:t>
+              <a:t>6/15/26</a:t>
             </a:fld>
             <a:endParaRPr lang="en-US"/>
           </a:p>
@@ -2521,7 +2521,7 @@
           <a:p>
             <a:fld id="{5BCAD085-E8A6-8845-BD4E-CB4CCA059FC4}" type="datetimeFigureOut">
               <a:rPr lang="en-US" smtClean="0"/>
-              <a:t>6/14/26</a:t>
+              <a:t>6/15/26</a:t>
             </a:fld>
             <a:endParaRPr lang="en-US"/>
           </a:p>
@@ -2732,7 +2732,7 @@
           <a:p>
             <a:fld id="{5BCAD085-E8A6-8845-BD4E-CB4CCA059FC4}" type="datetimeFigureOut">
               <a:rPr lang="en-US" smtClean="0"/>
-              <a:t>6/14/26</a:t>
+              <a:t>6/15/26</a:t>
             </a:fld>
             <a:endParaRPr lang="en-US"/>
           </a:p>
@@ -17218,7 +17218,7 @@
         </p:nvSpPr>
         <p:spPr>
           <a:xfrm>
-            <a:off x="320040" y="713232"/>
+            <a:off x="320040" y="749808"/>
             <a:ext cx="11430000" cy="347472"/>
           </a:xfrm>
           <a:prstGeom prst="rect">
@@ -17254,7 +17254,7 @@
         <p:spPr>
           <a:xfrm>
             <a:off x="182880" y="1188720"/>
-            <a:ext cx="2103120" cy="475488"/>
+            <a:ext cx="1725664" cy="475488"/>
           </a:xfrm>
           <a:prstGeom prst="rect">
             <a:avLst/>
@@ -17298,7 +17298,7 @@
         <p:spPr>
           <a:xfrm>
             <a:off x="182880" y="1188720"/>
-            <a:ext cx="2103120" cy="475488"/>
+            <a:ext cx="1725664" cy="369332"/>
           </a:xfrm>
           <a:prstGeom prst="rect">
             <a:avLst/>
@@ -17333,7 +17333,7 @@
         <p:spPr>
           <a:xfrm>
             <a:off x="182880" y="1664208"/>
-            <a:ext cx="2103120" cy="2724912"/>
+            <a:ext cx="1725664" cy="2724912"/>
           </a:xfrm>
           <a:prstGeom prst="rect">
             <a:avLst/>
@@ -17377,7 +17377,7 @@
         <p:spPr>
           <a:xfrm>
             <a:off x="274320" y="1737360"/>
-            <a:ext cx="1920240" cy="2560320"/>
+            <a:ext cx="1575606" cy="1284967"/>
           </a:xfrm>
           <a:prstGeom prst="rect">
             <a:avLst/>
@@ -17464,7 +17464,7 @@
         <p:spPr>
           <a:xfrm>
             <a:off x="2432304" y="1188720"/>
-            <a:ext cx="2103120" cy="475488"/>
+            <a:ext cx="1725664" cy="475488"/>
           </a:xfrm>
           <a:prstGeom prst="rect">
             <a:avLst/>
@@ -17508,7 +17508,7 @@
         <p:spPr>
           <a:xfrm>
             <a:off x="2432304" y="1188720"/>
-            <a:ext cx="2103120" cy="475488"/>
+            <a:ext cx="1725664" cy="369332"/>
           </a:xfrm>
           <a:prstGeom prst="rect">
             <a:avLst/>
@@ -17523,7 +17523,7 @@
           <a:p>
             <a:pPr algn="ctr"/>
             <a:r>
-              <a:rPr sz="1800" b="1" i="0">
+              <a:rPr sz="1800" b="1" i="0" dirty="0" err="1">
                 <a:solidFill>
                   <a:srgbClr val="1E2D1E"/>
                 </a:solidFill>
@@ -17531,6 +17531,12 @@
               </a:rPr>
               <a:t>Functioneel</a:t>
             </a:r>
+            <a:endParaRPr sz="1800" b="1" i="0" dirty="0">
+              <a:solidFill>
+                <a:srgbClr val="1E2D1E"/>
+              </a:solidFill>
+              <a:latin typeface="Calibri"/>
+            </a:endParaRPr>
           </a:p>
         </p:txBody>
       </p:sp>
@@ -17543,7 +17549,7 @@
         <p:spPr>
           <a:xfrm>
             <a:off x="2432304" y="1664208"/>
-            <a:ext cx="2103120" cy="2724912"/>
+            <a:ext cx="1725664" cy="2724912"/>
           </a:xfrm>
           <a:prstGeom prst="rect">
             <a:avLst/>
@@ -17587,7 +17593,7 @@
         <p:spPr>
           <a:xfrm>
             <a:off x="2523744" y="1737360"/>
-            <a:ext cx="1920240" cy="2560320"/>
+            <a:ext cx="1575606" cy="1020792"/>
           </a:xfrm>
           <a:prstGeom prst="rect">
             <a:avLst/>
@@ -17657,8 +17663,8 @@
         </p:nvSpPr>
         <p:spPr>
           <a:xfrm>
-            <a:off x="4681728" y="1188720"/>
-            <a:ext cx="2103120" cy="475488"/>
+            <a:off x="4266919" y="1184383"/>
+            <a:ext cx="1725664" cy="475488"/>
           </a:xfrm>
           <a:prstGeom prst="rect">
             <a:avLst/>
@@ -17701,8 +17707,8 @@
         </p:nvSpPr>
         <p:spPr>
           <a:xfrm>
-            <a:off x="4681728" y="1188720"/>
-            <a:ext cx="2103120" cy="475488"/>
+            <a:off x="4266919" y="1184383"/>
+            <a:ext cx="1725664" cy="369332"/>
           </a:xfrm>
           <a:prstGeom prst="rect">
             <a:avLst/>
@@ -17736,8 +17742,8 @@
         </p:nvSpPr>
         <p:spPr>
           <a:xfrm>
-            <a:off x="4681728" y="1664208"/>
-            <a:ext cx="2103120" cy="2724912"/>
+            <a:off x="4266919" y="1659871"/>
+            <a:ext cx="1725664" cy="2724912"/>
           </a:xfrm>
           <a:prstGeom prst="rect">
             <a:avLst/>
@@ -17780,8 +17786,8 @@
         </p:nvSpPr>
         <p:spPr>
           <a:xfrm>
-            <a:off x="4773168" y="1737360"/>
-            <a:ext cx="1920240" cy="2560320"/>
+            <a:off x="4358359" y="1733023"/>
+            <a:ext cx="1575606" cy="1020792"/>
           </a:xfrm>
           <a:prstGeom prst="rect">
             <a:avLst/>
@@ -17851,8 +17857,8 @@
         </p:nvSpPr>
         <p:spPr>
           <a:xfrm>
-            <a:off x="6931152" y="1188720"/>
-            <a:ext cx="2103120" cy="475488"/>
+            <a:off x="6114040" y="1184383"/>
+            <a:ext cx="1725664" cy="475488"/>
           </a:xfrm>
           <a:prstGeom prst="rect">
             <a:avLst/>
@@ -17895,8 +17901,8 @@
         </p:nvSpPr>
         <p:spPr>
           <a:xfrm>
-            <a:off x="6931152" y="1188720"/>
-            <a:ext cx="2103120" cy="475488"/>
+            <a:off x="6114040" y="1184383"/>
+            <a:ext cx="1725664" cy="369332"/>
           </a:xfrm>
           <a:prstGeom prst="rect">
             <a:avLst/>
@@ -17930,8 +17936,8 @@
         </p:nvSpPr>
         <p:spPr>
           <a:xfrm>
-            <a:off x="6931152" y="1664208"/>
-            <a:ext cx="2103120" cy="2724912"/>
+            <a:off x="6114040" y="1659871"/>
+            <a:ext cx="1725664" cy="2724912"/>
           </a:xfrm>
           <a:prstGeom prst="rect">
             <a:avLst/>
@@ -17974,8 +17980,8 @@
         </p:nvSpPr>
         <p:spPr>
           <a:xfrm>
-            <a:off x="7022592" y="1737360"/>
-            <a:ext cx="1920240" cy="2560320"/>
+            <a:off x="6205480" y="1733023"/>
+            <a:ext cx="1575606" cy="1020792"/>
           </a:xfrm>
           <a:prstGeom prst="rect">
             <a:avLst/>
@@ -18045,8 +18051,8 @@
         </p:nvSpPr>
         <p:spPr>
           <a:xfrm>
-            <a:off x="9180576" y="1188720"/>
-            <a:ext cx="2103120" cy="475488"/>
+            <a:off x="7931144" y="1170432"/>
+            <a:ext cx="1725664" cy="475488"/>
           </a:xfrm>
           <a:prstGeom prst="rect">
             <a:avLst/>
@@ -18089,8 +18095,8 @@
         </p:nvSpPr>
         <p:spPr>
           <a:xfrm>
-            <a:off x="9180576" y="1188720"/>
-            <a:ext cx="2103120" cy="475488"/>
+            <a:off x="7931144" y="1170432"/>
+            <a:ext cx="1725664" cy="369332"/>
           </a:xfrm>
           <a:prstGeom prst="rect">
             <a:avLst/>
@@ -18124,8 +18130,8 @@
         </p:nvSpPr>
         <p:spPr>
           <a:xfrm>
-            <a:off x="9180576" y="1664208"/>
-            <a:ext cx="2103120" cy="2724912"/>
+            <a:off x="7931144" y="1645920"/>
+            <a:ext cx="1725664" cy="2724912"/>
           </a:xfrm>
           <a:prstGeom prst="rect">
             <a:avLst/>
@@ -18168,8 +18174,8 @@
         </p:nvSpPr>
         <p:spPr>
           <a:xfrm>
-            <a:off x="9272016" y="1737360"/>
-            <a:ext cx="1920240" cy="2560320"/>
+            <a:off x="8022584" y="1719072"/>
+            <a:ext cx="1575606" cy="1420902"/>
           </a:xfrm>
           <a:prstGeom prst="rect">
             <a:avLst/>
@@ -18282,8 +18288,8 @@
         </p:blipFill>
         <p:spPr>
           <a:xfrm>
-            <a:off x="274320" y="4892040"/>
-            <a:ext cx="2863761" cy="2651760"/>
+            <a:off x="274321" y="4892040"/>
+            <a:ext cx="2006364" cy="1857835"/>
           </a:xfrm>
           <a:prstGeom prst="rect">
             <a:avLst/>
@@ -18298,8 +18304,8 @@
         </p:nvSpPr>
         <p:spPr>
           <a:xfrm>
-            <a:off x="6126480" y="4572000"/>
-            <a:ext cx="5852160" cy="2103120"/>
+            <a:off x="4267117" y="4833728"/>
+            <a:ext cx="3535845" cy="1349087"/>
           </a:xfrm>
           <a:prstGeom prst="rect">
             <a:avLst/>
@@ -18393,6 +18399,263 @@
           </a:p>
         </p:txBody>
       </p:sp>
+      <p:sp>
+        <p:nvSpPr>
+          <p:cNvPr id="29" name="Rectangle 28">
+            <a:extLst>
+              <a:ext uri="{FF2B5EF4-FFF2-40B4-BE49-F238E27FC236}">
+                <a16:creationId xmlns:a16="http://schemas.microsoft.com/office/drawing/2014/main" id="{CCFC85BB-C0C5-7DE1-5A03-5450DB1A13A8}"/>
+              </a:ext>
+            </a:extLst>
+          </p:cNvPr>
+          <p:cNvSpPr/>
+          <p:nvPr/>
+        </p:nvSpPr>
+        <p:spPr>
+          <a:xfrm>
+            <a:off x="9828598" y="1170432"/>
+            <a:ext cx="1725664" cy="475488"/>
+          </a:xfrm>
+          <a:prstGeom prst="rect">
+            <a:avLst/>
+          </a:prstGeom>
+          <a:solidFill>
+            <a:srgbClr val="8E44AD"/>
+          </a:solidFill>
+          <a:ln>
+            <a:noFill/>
+          </a:ln>
+        </p:spPr>
+        <p:style>
+          <a:lnRef idx="1">
+            <a:schemeClr val="accent1"/>
+          </a:lnRef>
+          <a:fillRef idx="3">
+            <a:schemeClr val="accent1"/>
+          </a:fillRef>
+          <a:effectRef idx="2">
+            <a:schemeClr val="accent1"/>
+          </a:effectRef>
+          <a:fontRef idx="minor">
+            <a:schemeClr val="lt1"/>
+          </a:fontRef>
+        </p:style>
+        <p:txBody>
+          <a:bodyPr rtlCol="0" anchor="ctr"/>
+          <a:lstStyle/>
+          <a:p>
+            <a:pPr algn="ctr"/>
+            <a:endParaRPr/>
+          </a:p>
+        </p:txBody>
+      </p:sp>
+      <p:sp>
+        <p:nvSpPr>
+          <p:cNvPr id="30" name="TextBox 29">
+            <a:extLst>
+              <a:ext uri="{FF2B5EF4-FFF2-40B4-BE49-F238E27FC236}">
+                <a16:creationId xmlns:a16="http://schemas.microsoft.com/office/drawing/2014/main" id="{8F3F9E0D-E8F6-1AAC-08A0-45679D15F90D}"/>
+              </a:ext>
+            </a:extLst>
+          </p:cNvPr>
+          <p:cNvSpPr txBox="1"/>
+          <p:nvPr/>
+        </p:nvSpPr>
+        <p:spPr>
+          <a:xfrm>
+            <a:off x="9828598" y="1170432"/>
+            <a:ext cx="1725664" cy="369332"/>
+          </a:xfrm>
+          <a:prstGeom prst="rect">
+            <a:avLst/>
+          </a:prstGeom>
+          <a:noFill/>
+        </p:spPr>
+        <p:txBody>
+          <a:bodyPr wrap="square">
+            <a:spAutoFit/>
+          </a:bodyPr>
+          <a:lstStyle/>
+          <a:p>
+            <a:pPr algn="ctr"/>
+            <a:r>
+              <a:rPr lang="en-US" sz="1800" b="1" i="0" dirty="0">
+                <a:solidFill>
+                  <a:srgbClr val="1E2D1E"/>
+                </a:solidFill>
+                <a:latin typeface="Calibri"/>
+              </a:rPr>
+              <a:t>MFTT</a:t>
+            </a:r>
+            <a:endParaRPr sz="1800" b="1" i="0" dirty="0">
+              <a:solidFill>
+                <a:srgbClr val="1E2D1E"/>
+              </a:solidFill>
+              <a:latin typeface="Calibri"/>
+            </a:endParaRPr>
+          </a:p>
+        </p:txBody>
+      </p:sp>
+      <p:sp>
+        <p:nvSpPr>
+          <p:cNvPr id="31" name="Rectangle 30">
+            <a:extLst>
+              <a:ext uri="{FF2B5EF4-FFF2-40B4-BE49-F238E27FC236}">
+                <a16:creationId xmlns:a16="http://schemas.microsoft.com/office/drawing/2014/main" id="{4B4C01CA-8B65-F1C1-D038-EE0FD8A6D5C7}"/>
+              </a:ext>
+            </a:extLst>
+          </p:cNvPr>
+          <p:cNvSpPr/>
+          <p:nvPr/>
+        </p:nvSpPr>
+        <p:spPr>
+          <a:xfrm>
+            <a:off x="9828598" y="1645920"/>
+            <a:ext cx="1725664" cy="2724912"/>
+          </a:xfrm>
+          <a:prstGeom prst="rect">
+            <a:avLst/>
+          </a:prstGeom>
+          <a:solidFill>
+            <a:srgbClr val="2A402A"/>
+          </a:solidFill>
+          <a:ln>
+            <a:noFill/>
+          </a:ln>
+        </p:spPr>
+        <p:style>
+          <a:lnRef idx="1">
+            <a:schemeClr val="accent1"/>
+          </a:lnRef>
+          <a:fillRef idx="3">
+            <a:schemeClr val="accent1"/>
+          </a:fillRef>
+          <a:effectRef idx="2">
+            <a:schemeClr val="accent1"/>
+          </a:effectRef>
+          <a:fontRef idx="minor">
+            <a:schemeClr val="lt1"/>
+          </a:fontRef>
+        </p:style>
+        <p:txBody>
+          <a:bodyPr rtlCol="0" anchor="ctr"/>
+          <a:lstStyle/>
+          <a:p>
+            <a:pPr algn="ctr"/>
+            <a:endParaRPr/>
+          </a:p>
+        </p:txBody>
+      </p:sp>
+      <p:sp>
+        <p:nvSpPr>
+          <p:cNvPr id="32" name="TextBox 31">
+            <a:extLst>
+              <a:ext uri="{FF2B5EF4-FFF2-40B4-BE49-F238E27FC236}">
+                <a16:creationId xmlns:a16="http://schemas.microsoft.com/office/drawing/2014/main" id="{A6C6F7B2-1D77-3FB1-E96A-CF29074F2C6D}"/>
+              </a:ext>
+            </a:extLst>
+          </p:cNvPr>
+          <p:cNvSpPr txBox="1"/>
+          <p:nvPr/>
+        </p:nvSpPr>
+        <p:spPr>
+          <a:xfrm>
+            <a:off x="9920038" y="1719072"/>
+            <a:ext cx="1575606" cy="987450"/>
+          </a:xfrm>
+          <a:prstGeom prst="rect">
+            <a:avLst/>
+          </a:prstGeom>
+          <a:noFill/>
+        </p:spPr>
+        <p:txBody>
+          <a:bodyPr wrap="square">
+            <a:spAutoFit/>
+          </a:bodyPr>
+          <a:lstStyle/>
+          <a:p>
+            <a:pPr>
+              <a:spcAft>
+                <a:spcPts val="500"/>
+              </a:spcAft>
+            </a:pPr>
+            <a:r>
+              <a:rPr lang="nl-BE" sz="1400" dirty="0">
+                <a:solidFill>
+                  <a:schemeClr val="bg1"/>
+                </a:solidFill>
+              </a:rPr>
+              <a:t>Military Functional Fitness Training</a:t>
+            </a:r>
+            <a:r>
+              <a:rPr lang="en-BE" sz="1100" dirty="0">
+                <a:solidFill>
+                  <a:schemeClr val="bg1"/>
+                </a:solidFill>
+              </a:rPr>
+              <a:t> </a:t>
+            </a:r>
+            <a:endParaRPr lang="en-US" sz="1100" dirty="0">
+              <a:solidFill>
+                <a:schemeClr val="bg1"/>
+              </a:solidFill>
+              <a:latin typeface="Calibri"/>
+            </a:endParaRPr>
+          </a:p>
+          <a:p>
+            <a:pPr algn="l">
+              <a:spcAft>
+                <a:spcPts val="500"/>
+              </a:spcAft>
+            </a:pPr>
+            <a:r>
+              <a:rPr lang="en-US" sz="1300" dirty="0">
+                <a:solidFill>
+                  <a:srgbClr val="B0C09A"/>
+                </a:solidFill>
+                <a:latin typeface="Calibri"/>
+              </a:rPr>
+              <a:t>NIEUWE TESTEN 2026</a:t>
+            </a:r>
+            <a:endParaRPr sz="1300" dirty="0">
+              <a:solidFill>
+                <a:srgbClr val="B0C09A"/>
+              </a:solidFill>
+              <a:latin typeface="Calibri"/>
+            </a:endParaRPr>
+          </a:p>
+        </p:txBody>
+      </p:sp>
+      <p:pic>
+        <p:nvPicPr>
+          <p:cNvPr id="34" name="Picture 33">
+            <a:extLst>
+              <a:ext uri="{FF2B5EF4-FFF2-40B4-BE49-F238E27FC236}">
+                <a16:creationId xmlns:a16="http://schemas.microsoft.com/office/drawing/2014/main" id="{EFD9373D-CB91-D997-1FBC-8E379EE915F6}"/>
+              </a:ext>
+            </a:extLst>
+          </p:cNvPr>
+          <p:cNvPicPr>
+            <a:picLocks noChangeAspect="1"/>
+          </p:cNvPicPr>
+          <p:nvPr/>
+        </p:nvPicPr>
+        <p:blipFill>
+          <a:blip r:embed="rId3"/>
+          <a:stretch>
+            <a:fillRect/>
+          </a:stretch>
+        </p:blipFill>
+        <p:spPr>
+          <a:xfrm>
+            <a:off x="8490162" y="4660102"/>
+            <a:ext cx="2333292" cy="2197898"/>
+          </a:xfrm>
+          <a:prstGeom prst="rect">
+            <a:avLst/>
+          </a:prstGeom>
+        </p:spPr>
+      </p:pic>
     </p:spTree>
   </p:cSld>
   <p:clrMapOvr>

</xml_diff>